<commit_message>
Adopt 15-session program: reading-15.md selects 23 papers with in-context summaries
New structure: 1 instructor intro, 15 paper sessions (7 singles, 8
pairs of which 3 are debates), 4 project-presentation classes.
reading-15.md gives each session a contextual summary tracing the
three-act arc, plus a swaps list and presenter-slot math. Schedule,
format rules, milestones, and cross-references updated across syllabus,
README, readings.md, and reality-checks.md; Baldur example deck
regenerated for its new slot (S13, Thu Feb 18, paired with DSP).

Co-Authored-By: Claude Fable 5 <noreply@anthropic.com>
Claude-Session: https://claude.ai/code/session_0145Uf2BPH5pDAioje6wcBsb
</commit_message>
<xml_diff>
--- a/slides/39 - Baldur - example presentation.pptx
+++ b/slides/39 - Baldur - example presentation.pptx
@@ -1798,7 +1798,7 @@
                 <a:ea typeface="Calibri" pitchFamily="34" charset="-122"/>
                 <a:cs typeface="Calibri" pitchFamily="34" charset="-120"/>
               </a:rPr>
-              <a:t>PAPER PRESENTATION · READING #39 · SESSION 17</a:t>
+              <a:t>PAPER PRESENTATION · READING #39 · SESSION 13 · PAIRED WITH #40 DRAFT, SKETCH &amp; PROVE</a:t>
             </a:r>
             <a:endParaRPr lang="en-US" sz="1300" dirty="0"/>
           </a:p>
@@ -2005,7 +2005,7 @@
                 <a:ea typeface="Calibri" pitchFamily="34" charset="-122"/>
                 <a:cs typeface="Calibri" pitchFamily="34" charset="-120"/>
               </a:rPr>
-              <a:t>  ·  Tue Mar 2, 2027</a:t>
+              <a:t>  ·  Thu Feb 18, 2027</a:t>
             </a:r>
             <a:endParaRPr lang="en-US" sz="1500" dirty="0"/>
           </a:p>

</xml_diff>